<commit_message>
Update proposal PPTX: Fiore Legal (July 1, 2026) — FCOO + FCFO package, Run 2
- Package 2 updated to Master's Circle + FCOO + FCFO Advisors ($7,991/mo bundled)
- Total investment updated to $15,388/mo; savings $4,200/mo
- Urgency score corrected to 8; competitor table updated with live review counts
- Slide 2 priorities reflect FCOO/FCFO as primary (not Phase 2/3) recommendations
- Closing quote tied to Mauro's DBM: 8 offices running without founder in the loop

Co-Authored-By: Claude Sonnet 4.6 <noreply@anthropic.com>
</commit_message>
<xml_diff>
--- a/fiore-legal/FioreLegal_July1_2026_Proposal.pptx
+++ b/fiore-legal/FioreLegal_July1_2026_Proposal.pptx
@@ -3319,7 +3319,7 @@
                 </a:solidFill>
                 <a:latin typeface="Calibri"/>
               </a:rPr>
-              <a:t>7</a:t>
+              <a:t>8</a:t>
             </a:r>
           </a:p>
         </p:txBody>
@@ -3541,7 +3541,7 @@
                 </a:solidFill>
                 <a:latin typeface="Calibri"/>
               </a:rPr>
-              <a:t>No paid ads observed</a:t>
+              <a:t>No paid ads in any market</a:t>
             </a:r>
           </a:p>
         </p:txBody>
@@ -3697,7 +3697,7 @@
                 </a:solidFill>
                 <a:latin typeface="Calibri"/>
               </a:rPr>
-              <a:t>AMBER</a:t>
+              <a:t>NEEDS WORK</a:t>
             </a:r>
           </a:p>
         </p:txBody>
@@ -3730,7 +3730,7 @@
                 </a:solidFill>
                 <a:latin typeface="Calibri"/>
               </a:rPr>
-              <a:t>No intake team confirmed</a:t>
+              <a:t>No after-hours coverage</a:t>
             </a:r>
           </a:p>
         </p:txBody>
@@ -3886,7 +3886,7 @@
                 </a:solidFill>
                 <a:latin typeface="Calibri"/>
               </a:rPr>
-              <a:t>AMBER</a:t>
+              <a:t>NEEDS WORK</a:t>
             </a:r>
           </a:p>
         </p:txBody>
@@ -4075,7 +4075,7 @@
                 </a:solidFill>
                 <a:latin typeface="Calibri"/>
               </a:rPr>
-              <a:t>AMBER</a:t>
+              <a:t>NEEDS WORK</a:t>
             </a:r>
           </a:p>
         </p:txBody>
@@ -4297,7 +4297,7 @@
                 </a:solidFill>
                 <a:latin typeface="Calibri"/>
               </a:rPr>
-              <a:t>Competitors own all paid PI search in LA — Fiore Legal is invisible in Google Ads, LSA, and Meta.</a:t>
+              <a:t>No paid advertising across Google, LSA, or Meta — competitors own every high-intent PI search in all 8 markets while Fiore Legal relies on organic reputation alone.</a:t>
             </a:r>
           </a:p>
         </p:txBody>
@@ -4453,7 +4453,7 @@
                 </a:solidFill>
                 <a:latin typeface="Calibri"/>
               </a:rPr>
-              <a:t>8 offices with no confirmed intake system — leads lost with no visibility into how many.</a:t>
+              <a:t>Eight offices with no confirmed intake system — leads are being lost across locations with no visibility into how many or where, a problem that compounds when paid volume begins.</a:t>
             </a:r>
           </a:p>
         </p:txBody>
@@ -4609,7 +4609,7 @@
                 </a:solidFill>
                 <a:latin typeface="Calibri"/>
               </a:rPr>
-              <a:t>No ops layer across 9 attorneys — growth capped by founder's personal involvement.</a:t>
+              <a:t>No ops or management layer across 9 attorneys and 8 offices — the firm's growth is structurally capped by founder involvement in decisions at every location.</a:t>
             </a:r>
           </a:p>
         </p:txBody>
@@ -4765,7 +4765,7 @@
                 </a:solidFill>
                 <a:latin typeface="Calibri"/>
               </a:rPr>
-              <a:t>25-year brand + 8 locations + bilingual team = a powerful foundation ready to scale digitally.</a:t>
+              <a:t>Eight physical locations + 25-year reputation + $250M recovered = structural market advantage that paid marketing can multiply immediately across every market served.</a:t>
             </a:r>
           </a:p>
         </p:txBody>
@@ -4966,7 +4966,7 @@
                 </a:solidFill>
                 <a:latin typeface="Calibri"/>
               </a:rPr>
-              <a:t>Stage 4: Small Business Manager  →  Goal: Stage 6, Law Firm Owner</a:t>
+              <a:t>Stage 4: Small Business Manager  →  Goal: Law Firm CEO / Owner</a:t>
             </a:r>
           </a:p>
         </p:txBody>
@@ -5077,7 +5077,7 @@
                 </a:solidFill>
                 <a:latin typeface="Calibri"/>
               </a:rPr>
-              <a:t>Downtown LA Law Group</a:t>
+              <a:t>West Coast Trial Lawyers</a:t>
             </a:r>
           </a:p>
         </p:txBody>
@@ -5110,7 +5110,7 @@
                 </a:solidFill>
                 <a:latin typeface="Calibri"/>
               </a:rPr>
-              <a:t>624+ Avvo reviews</a:t>
+              <a:t>510 reviews / 4.9★</a:t>
             </a:r>
           </a:p>
         </p:txBody>
@@ -5143,7 +5143,7 @@
                 </a:solidFill>
                 <a:latin typeface="Calibri"/>
               </a:rPr>
-              <a:t>bilingual · 11+ markets</a:t>
+              <a:t>Full digital stack · all PI verticals</a:t>
             </a:r>
           </a:p>
         </p:txBody>
@@ -5221,7 +5221,7 @@
                 </a:solidFill>
                 <a:latin typeface="Calibri"/>
               </a:rPr>
-              <a:t>Sweet James Accident Attys</a:t>
+              <a:t>Downtown LA Law Group</a:t>
             </a:r>
           </a:p>
         </p:txBody>
@@ -5254,7 +5254,7 @@
                 </a:solidFill>
                 <a:latin typeface="Calibri"/>
               </a:rPr>
-              <a:t>600+ Google/Yelp</a:t>
+              <a:t>284 reviews / 4.9★</a:t>
             </a:r>
           </a:p>
         </p:txBody>
@@ -5287,7 +5287,7 @@
                 </a:solidFill>
                 <a:latin typeface="Calibri"/>
               </a:rPr>
-              <a:t>$22M verdict · multi-state</a:t>
+              <a:t>Bilingual · 624 Avvo · 11+ markets</a:t>
             </a:r>
           </a:p>
         </p:txBody>
@@ -5398,7 +5398,7 @@
                 </a:solidFill>
                 <a:latin typeface="Calibri"/>
               </a:rPr>
-              <a:t>102 Avvo reviews</a:t>
+              <a:t>475 reviews / 4.8★</a:t>
             </a:r>
           </a:p>
         </p:txBody>
@@ -5431,7 +5431,7 @@
                 </a:solidFill>
                 <a:latin typeface="Calibri"/>
               </a:rPr>
-              <a:t>LA/Pasadena overlap</a:t>
+              <a:t>SGV overlap · Best Lawyers 2026</a:t>
             </a:r>
           </a:p>
         </p:txBody>
@@ -5587,7 +5587,7 @@
                 </a:solidFill>
                 <a:latin typeface="Calibri"/>
               </a:rPr>
-              <a:t>Not yet verified</a:t>
+              <a:t>11 reviews / 3.2★</a:t>
             </a:r>
           </a:p>
         </p:txBody>
@@ -5860,7 +5860,7 @@
                 </a:solidFill>
                 <a:latin typeface="Calibri"/>
               </a:rPr>
-              <a:t>Your Growth Plan: 3 Priorities to Scale All 8 Markets</a:t>
+              <a:t>Your Growth Plan: 3 Priorities to Reach Market Dominance</a:t>
             </a:r>
           </a:p>
         </p:txBody>
@@ -6016,7 +6016,7 @@
                 </a:solidFill>
                 <a:latin typeface="Calibri"/>
               </a:rPr>
-              <a:t>Lead Generation, Intake, Team, and Profit must all work together — missing any one means growth stalls regardless of effort or ad spend. When all four pillars are built, Mauro can step back and trust the firm generates consistent case flow without him personally driving every relationship.</a:t>
+              <a:t>Four pillars — Marketing, Intake, Team, and Profit — all running in parallel, across every one of your eight locations. When the system is built right, Fiore Legal generates cases, converts them, and tracks the return — without Mauro driving every decision.</a:t>
             </a:r>
           </a:p>
         </p:txBody>
@@ -6094,7 +6094,7 @@
                 </a:solidFill>
                 <a:latin typeface="Calibri"/>
               </a:rPr>
-              <a:t>$1.5M → $3M+ annual revenue</a:t>
+              <a:t>$1.5M → $3M+ revenue</a:t>
             </a:r>
           </a:p>
         </p:txBody>
@@ -6127,7 +6127,7 @@
                 </a:solidFill>
                 <a:latin typeface="Calibri"/>
               </a:rPr>
-              <a:t>A firm that grows without Mauro at the center</a:t>
+              <a:t>Eight offices running — without me in every decision</a:t>
             </a:r>
           </a:p>
         </p:txBody>
@@ -6394,7 +6394,7 @@
                 </a:solidFill>
                 <a:latin typeface="Calibri"/>
               </a:rPr>
-              <a:t>Launch Google Ads for PI/MVA across all 8 markets</a:t>
+              <a:t>Turn Google into a lead machine in all 8 markets</a:t>
             </a:r>
           </a:p>
         </p:txBody>
@@ -6517,7 +6517,7 @@
                 </a:solidFill>
                 <a:latin typeface="Calibri"/>
               </a:rPr>
-              <a:t>Get Google Screened — activate LSA firm-wide</a:t>
+              <a:t>Launch Spanish campaigns — same cases, lower CPLs</a:t>
             </a:r>
           </a:p>
         </p:txBody>
@@ -6640,7 +6640,7 @@
                 </a:solidFill>
                 <a:latin typeface="Calibri"/>
               </a:rPr>
-              <a:t>Launch Spanish PI campaigns — lower CPL, same ROI</a:t>
+              <a:t>Get Google Screened — appear above ads in LSA</a:t>
             </a:r>
           </a:p>
         </p:txBody>
@@ -6763,7 +6763,7 @@
                 </a:solidFill>
                 <a:latin typeface="Calibri"/>
               </a:rPr>
-              <a:t>Build geo landing pages for all 8 office cities</a:t>
+              <a:t>Build city pages per office — rank where you practice</a:t>
             </a:r>
           </a:p>
         </p:txBody>
@@ -6886,7 +6886,7 @@
                 </a:solidFill>
                 <a:latin typeface="Calibri"/>
               </a:rPr>
-              <a:t>A digital engine generating cases around the clock</a:t>
+              <a:t>Close the 46x review gap vs. top LA competitors</a:t>
             </a:r>
           </a:p>
         </p:txBody>
@@ -7153,7 +7153,7 @@
                 </a:solidFill>
                 <a:latin typeface="Calibri"/>
               </a:rPr>
-              <a:t>Deploy after-hours coverage across all 8 offices</a:t>
+              <a:t>Deploy after-hours intake across all 8 locations</a:t>
             </a:r>
           </a:p>
         </p:txBody>
@@ -7276,7 +7276,7 @@
                 </a:solidFill>
                 <a:latin typeface="Calibri"/>
               </a:rPr>
-              <a:t>Standardize lead follow-up across every location</a:t>
+              <a:t>Standardize scripts and response times firm-wide</a:t>
             </a:r>
           </a:p>
         </p:txBody>
@@ -7399,7 +7399,7 @@
                 </a:solidFill>
                 <a:latin typeface="Calibri"/>
               </a:rPr>
-              <a:t>Bilingual intake for Spanish-speaking PI clients</a:t>
+              <a:t>Capture every PI lead in minutes, not hours</a:t>
             </a:r>
           </a:p>
         </p:txBody>
@@ -7522,7 +7522,7 @@
                 </a:solidFill>
                 <a:latin typeface="Calibri"/>
               </a:rPr>
-              <a:t>Eliminate the gap between lead and consultation</a:t>
+              <a:t>Track follow-up rate by location — find the leaks</a:t>
             </a:r>
           </a:p>
         </p:txBody>
@@ -7645,7 +7645,7 @@
                 </a:solidFill>
                 <a:latin typeface="Calibri"/>
               </a:rPr>
-              <a:t>Never lose a signed case to a slow response again</a:t>
+              <a:t>Convert leads your 25-year brand already earns</a:t>
             </a:r>
           </a:p>
         </p:txBody>
@@ -7912,7 +7912,7 @@
                 </a:solidFill>
                 <a:latin typeface="Calibri"/>
               </a:rPr>
-              <a:t>Build an ops layer to manage 8 locations</a:t>
+              <a:t>Build ops layer — Mauro exits daily decisions</a:t>
             </a:r>
           </a:p>
         </p:txBody>
@@ -8035,7 +8035,7 @@
                 </a:solidFill>
                 <a:latin typeface="Calibri"/>
               </a:rPr>
-              <a:t>Establish location-level P&amp;L for each office</a:t>
+              <a:t>Deploy FCOO to structure accountability firm-wide</a:t>
             </a:r>
           </a:p>
         </p:txBody>
@@ -8158,7 +8158,7 @@
                 </a:solidFill>
                 <a:latin typeface="Calibri"/>
               </a:rPr>
-              <a:t>Create KPIs and accountability firm-wide</a:t>
+              <a:t>Establish location P&amp;L — see which offices profit</a:t>
             </a:r>
           </a:p>
         </p:txBody>
@@ -8281,7 +8281,7 @@
                 </a:solidFill>
                 <a:latin typeface="Calibri"/>
               </a:rPr>
-              <a:t>Confirm revenue baseline in first 90 days</a:t>
+              <a:t>FCFO sets revenue baseline in the first 90 days</a:t>
             </a:r>
           </a:p>
         </p:txBody>
@@ -8404,7 +8404,7 @@
                 </a:solidFill>
                 <a:latin typeface="Calibri"/>
               </a:rPr>
-              <a:t>Free Mauro from daily operational decisions</a:t>
+              <a:t>Scale case volume without growing owner workload</a:t>
             </a:r>
           </a:p>
         </p:txBody>
@@ -8944,7 +8944,7 @@
                 </a:solidFill>
                 <a:latin typeface="Calibri"/>
               </a:rPr>
-              <a:t>Google Ads · LSA · Meta · Spanish campaigns · GBP · SEO</a:t>
+              <a:t>Google Ads · LSA · Meta · Spanish campaigns · 8-market GBP</a:t>
             </a:r>
           </a:p>
         </p:txBody>
@@ -9067,7 +9067,7 @@
                 </a:solidFill>
                 <a:latin typeface="Calibri"/>
               </a:rPr>
-              <a:t>MASTER'S CIRCLE</a:t>
+              <a:t>MASTER'S CIRCLE + FCOO + FCFO ADVISORS</a:t>
             </a:r>
           </a:p>
         </p:txBody>
@@ -9100,7 +9100,7 @@
                 </a:solidFill>
                 <a:latin typeface="Calibri"/>
               </a:rPr>
-              <a:t>$4,600</a:t>
+              <a:t>$7,991</a:t>
             </a:r>
           </a:p>
         </p:txBody>
@@ -9166,7 +9166,7 @@
                 </a:solidFill>
                 <a:latin typeface="Calibri"/>
               </a:rPr>
-              <a:t>$4,997/mo</a:t>
+              <a:t>$10,591/mo</a:t>
             </a:r>
           </a:p>
         </p:txBody>
@@ -9244,7 +9244,7 @@
                 </a:solidFill>
                 <a:latin typeface="Calibri"/>
               </a:rPr>
-              <a:t>Weekly coaching · PI masterminds · Quarterly workshops</a:t>
+              <a:t>Weekly coaching · Fractional COO &amp; CFO · 8-location P&amp;L</a:t>
             </a:r>
           </a:p>
         </p:txBody>
@@ -9355,7 +9355,7 @@
                 </a:solidFill>
                 <a:latin typeface="Calibri"/>
               </a:rPr>
-              <a:t>$11,997 / mo</a:t>
+              <a:t>$15,388 / mo</a:t>
             </a:r>
           </a:p>
         </p:txBody>
@@ -9388,7 +9388,7 @@
                 </a:solidFill>
                 <a:latin typeface="Calibri"/>
               </a:rPr>
-              <a:t>Save $1,997/mo by bundling</a:t>
+              <a:t>Save $4,200/mo by bundling</a:t>
             </a:r>
           </a:p>
         </p:txBody>
@@ -9931,7 +9931,7 @@
                 </a:solidFill>
                 <a:latin typeface="Calibri"/>
               </a:rPr>
-              <a:t>Google Ads + LSA launched for PI in primary LA markets</a:t>
+              <a:t>Google Ads + LSA live: MVA, PI, and workers' comp</a:t>
             </a:r>
           </a:p>
         </p:txBody>
@@ -10042,7 +10042,7 @@
                 </a:solidFill>
                 <a:latin typeface="Calibri"/>
               </a:rPr>
-              <a:t>Spanish-language PI campaign live across LA</a:t>
+              <a:t>Spanish PI paid campaigns launched in Los Angeles</a:t>
             </a:r>
           </a:p>
         </p:txBody>
@@ -10153,7 +10153,7 @@
                 </a:solidFill>
                 <a:latin typeface="Calibri"/>
               </a:rPr>
-              <a:t>GBP optimization + review strategy deployed firm-wide</a:t>
+              <a:t>GBP review strategy deployed across all 8 offices</a:t>
             </a:r>
           </a:p>
         </p:txBody>
@@ -10264,7 +10264,7 @@
                 </a:solidFill>
                 <a:latin typeface="Calibri"/>
               </a:rPr>
-              <a:t>City landing pages started for 4 primary office markets</a:t>
+              <a:t>FCOO + FCFO kickoff; revenue baseline + P&amp;L initiated</a:t>
             </a:r>
           </a:p>
         </p:txBody>
@@ -10375,7 +10375,7 @@
                 </a:solidFill>
                 <a:latin typeface="Calibri"/>
               </a:rPr>
-              <a:t>Intake system standardized across all 8 locations</a:t>
+              <a:t>City SEO pages live; coaching KPIs and cadence set</a:t>
             </a:r>
           </a:p>
         </p:txBody>
@@ -10453,7 +10453,7 @@
                 </a:solidFill>
                 <a:latin typeface="Calibri"/>
               </a:rPr>
-              <a:t>"Every one of your 8 locations generating consistent case flow from digital — not because you're there, but because the system is."</a:t>
+              <a:t>"Twenty-five years building the reputation. Now we build the system that makes all eight locations generate leads — without me at the center of it."</a:t>
             </a:r>
           </a:p>
         </p:txBody>

</xml_diff>